<commit_message>
consulting_paper theme: paper canvas, muted slate palette, larger type scale
- deck_builder paints every slide background from theme.color_bg (the
  warm-paper depth effect from the real Gates master template)
- themes/consulting_paper.json: cream F2F1EC canvas, slate 51626F bands,
  charcoal ink, sienna accent, warm grid grays, body 11pt / micro 8.5pt
- showcase re-rendered on the new theme; delivered to user folder

Gap analysis vs the real Gates deck captured: remaining polish items are
yellow highlight pills, white body panels with shadows, map/image
watermarks, superscript footnote refs.
</commit_message>
<xml_diff>
--- a/eval/out/agdev_demo.pptx
+++ b/eval/out/agdev_demo.pptx
@@ -3086,6 +3086,14 @@
 <file path=ppt/slides/slide1.xml><?xml version="1.0" encoding="utf-8"?>
 <p:sld xmlns:a="http://schemas.openxmlformats.org/drawingml/2006/main" xmlns:p="http://schemas.openxmlformats.org/presentationml/2006/main" xmlns:r="http://schemas.openxmlformats.org/officeDocument/2006/relationships">
   <p:cSld>
+    <p:bg>
+      <p:bgPr>
+        <a:solidFill>
+          <a:srgbClr val="FFFFFF"/>
+        </a:solidFill>
+        <a:effectLst/>
+      </p:bgPr>
+    </p:bg>
     <p:spTree>
       <p:nvGrpSpPr>
         <p:cNvPr id="1" name=""/>
@@ -3428,6 +3436,14 @@
 <file path=ppt/slides/slide2.xml><?xml version="1.0" encoding="utf-8"?>
 <p:sld xmlns:a="http://schemas.openxmlformats.org/drawingml/2006/main" xmlns:p="http://schemas.openxmlformats.org/presentationml/2006/main" xmlns:r="http://schemas.openxmlformats.org/officeDocument/2006/relationships">
   <p:cSld>
+    <p:bg>
+      <p:bgPr>
+        <a:solidFill>
+          <a:srgbClr val="FFFFFF"/>
+        </a:solidFill>
+        <a:effectLst/>
+      </p:bgPr>
+    </p:bg>
     <p:spTree>
       <p:nvGrpSpPr>
         <p:cNvPr id="1" name=""/>
@@ -4938,6 +4954,14 @@
 <file path=ppt/slides/slide3.xml><?xml version="1.0" encoding="utf-8"?>
 <p:sld xmlns:a="http://schemas.openxmlformats.org/drawingml/2006/main" xmlns:p="http://schemas.openxmlformats.org/presentationml/2006/main" xmlns:r="http://schemas.openxmlformats.org/officeDocument/2006/relationships">
   <p:cSld>
+    <p:bg>
+      <p:bgPr>
+        <a:solidFill>
+          <a:srgbClr val="FFFFFF"/>
+        </a:solidFill>
+        <a:effectLst/>
+      </p:bgPr>
+    </p:bg>
     <p:spTree>
       <p:nvGrpSpPr>
         <p:cNvPr id="1" name=""/>
@@ -5213,6 +5237,14 @@
 <file path=ppt/slides/slide4.xml><?xml version="1.0" encoding="utf-8"?>
 <p:sld xmlns:a="http://schemas.openxmlformats.org/drawingml/2006/main" xmlns:p="http://schemas.openxmlformats.org/presentationml/2006/main" xmlns:r="http://schemas.openxmlformats.org/officeDocument/2006/relationships">
   <p:cSld>
+    <p:bg>
+      <p:bgPr>
+        <a:solidFill>
+          <a:srgbClr val="FFFFFF"/>
+        </a:solidFill>
+        <a:effectLst/>
+      </p:bgPr>
+    </p:bg>
     <p:spTree>
       <p:nvGrpSpPr>
         <p:cNvPr id="1" name=""/>
@@ -12798,6 +12830,14 @@
 <file path=ppt/slides/slide5.xml><?xml version="1.0" encoding="utf-8"?>
 <p:sld xmlns:a="http://schemas.openxmlformats.org/drawingml/2006/main" xmlns:p="http://schemas.openxmlformats.org/presentationml/2006/main" xmlns:r="http://schemas.openxmlformats.org/officeDocument/2006/relationships">
   <p:cSld>
+    <p:bg>
+      <p:bgPr>
+        <a:solidFill>
+          <a:srgbClr val="FFFFFF"/>
+        </a:solidFill>
+        <a:effectLst/>
+      </p:bgPr>
+    </p:bg>
     <p:spTree>
       <p:nvGrpSpPr>
         <p:cNvPr id="1" name=""/>
@@ -21026,6 +21066,14 @@
 <file path=ppt/slides/slide6.xml><?xml version="1.0" encoding="utf-8"?>
 <p:sld xmlns:a="http://schemas.openxmlformats.org/drawingml/2006/main" xmlns:p="http://schemas.openxmlformats.org/presentationml/2006/main" xmlns:r="http://schemas.openxmlformats.org/officeDocument/2006/relationships">
   <p:cSld>
+    <p:bg>
+      <p:bgPr>
+        <a:solidFill>
+          <a:srgbClr val="FFFFFF"/>
+        </a:solidFill>
+        <a:effectLst/>
+      </p:bgPr>
+    </p:bg>
     <p:spTree>
       <p:nvGrpSpPr>
         <p:cNvPr id="1" name=""/>

</xml_diff>

<commit_message>
Q1a: full-bleed cover + colour-block divider, highlight pills, superscripts, icon tiles
Human-craft elements replicated from the reference Gates deck:
- title slide: full-bleed charcoal canvas, oversized serif in cream, org
  wordmark bleeding off the bottom edge (schema: wordmark field)
- section_divider: bold full-slide accent colour-block, centered (style=bleed)
  with a bar variant retained
- rich text: [[hl]]...[[/]] -> yellow highlight pill behind the run (the
  consulting number signature); ^1 / ^{12} -> superscript footnote refs.
  Correct OOXML: <a:highlight> inserted before a:latin per CT schema;
  baseline=30000 for superscript
- color_highlight theme role (all 3 themes)
- icon_tile_row component: dark rounded icon tiles + alternating bands
  (reference impact-slide rail)
- render/xml_utils.py: add_soft_shadow (outerShdw) + add_shape(shadow=True)

131 tests; eval green; COM-verified title/divider/pills.
</commit_message>
<xml_diff>
--- a/eval/out/agdev_demo.pptx
+++ b/eval/out/agdev_demo.pptx
@@ -3109,14 +3109,14 @@
         </p:nvSpPr>
         <p:spPr>
           <a:xfrm>
-            <a:off x="0" y="2286000"/>
-            <a:ext cx="12192000" cy="54864"/>
+            <a:off x="0" y="0"/>
+            <a:ext cx="12192000" cy="6858000"/>
           </a:xfrm>
           <a:prstGeom prst="rect">
             <a:avLst/>
           </a:prstGeom>
           <a:solidFill>
-            <a:srgbClr val="C55A11"/>
+            <a:srgbClr val="16294A"/>
           </a:solidFill>
           <a:ln>
             <a:noFill/>
@@ -3153,8 +3153,8 @@
         </p:nvSpPr>
         <p:spPr>
           <a:xfrm>
-            <a:off x="914400" y="2606040"/>
-            <a:ext cx="10363200" cy="865808"/>
+            <a:off x="9265920" y="320040"/>
+            <a:ext cx="2560320" cy="274320"/>
           </a:xfrm>
           <a:prstGeom prst="rect">
             <a:avLst/>
@@ -3167,9 +3167,51 @@
           </a:bodyPr>
           <a:lstStyle/>
           <a:p>
+            <a:pPr algn="r">
+              <a:spcBef>
+                <a:spcPts val="0"/>
+              </a:spcBef>
+              <a:spcAft>
+                <a:spcPts val="0"/>
+              </a:spcAft>
+            </a:pPr>
+            <a:r>
+              <a:rPr sz="900" b="0" i="0">
+                <a:solidFill>
+                  <a:srgbClr val="FFFFFF"/>
+                </a:solidFill>
+                <a:latin typeface="Segoe UI"/>
+              </a:rPr>
+              <a:t>6 July 2026</a:t>
+            </a:r>
+          </a:p>
+        </p:txBody>
+      </p:sp>
+      <p:sp>
+        <p:nvSpPr>
+          <p:cNvPr id="4" name="TextBox 3"/>
+          <p:cNvSpPr txBox="1"/>
+          <p:nvPr/>
+        </p:nvSpPr>
+        <p:spPr>
+          <a:xfrm>
+            <a:off x="1005840" y="1371600"/>
+            <a:ext cx="10180320" cy="1154410"/>
+          </a:xfrm>
+          <a:prstGeom prst="rect">
+            <a:avLst/>
+          </a:prstGeom>
+          <a:noFill/>
+        </p:spPr>
+        <p:txBody>
+          <a:bodyPr wrap="square" lIns="0" rIns="0" tIns="0" bIns="0" anchor="t">
+            <a:noAutofit/>
+          </a:bodyPr>
+          <a:lstStyle/>
+          <a:p>
             <a:pPr algn="l">
               <a:lnSpc>
-                <a:spcPts val="3408"/>
+                <a:spcPts val="4544"/>
               </a:lnSpc>
               <a:spcBef>
                 <a:spcPts val="0"/>
@@ -3179,64 +3221,46 @@
               </a:spcAft>
             </a:pPr>
             <a:r>
-              <a:rPr sz="3000" b="0" i="0">
-                <a:solidFill>
-                  <a:srgbClr val="1F3864"/>
+              <a:rPr sz="4000" b="0" i="0">
+                <a:solidFill>
+                  <a:srgbClr val="FFFFFF"/>
                 </a:solidFill>
                 <a:latin typeface="Georgia"/>
               </a:rPr>
               <a:t>Agricultural </a:t>
             </a:r>
             <a:r>
-              <a:rPr sz="3000" b="0" i="0">
-                <a:solidFill>
-                  <a:srgbClr val="1F3864"/>
+              <a:rPr sz="4000" b="0" i="0">
+                <a:solidFill>
+                  <a:srgbClr val="FFFFFF"/>
                 </a:solidFill>
                 <a:latin typeface="Georgia"/>
               </a:rPr>
               <a:t>Development </a:t>
             </a:r>
             <a:r>
-              <a:rPr sz="3000" b="0" i="0">
-                <a:solidFill>
-                  <a:srgbClr val="1F3864"/>
+              <a:rPr sz="4000" b="0" i="0">
+                <a:solidFill>
+                  <a:srgbClr val="FFFFFF"/>
                 </a:solidFill>
                 <a:latin typeface="Georgia"/>
               </a:rPr>
               <a:t>in </a:t>
             </a:r>
             <a:r>
-              <a:rPr sz="3000" b="0" i="0">
-                <a:solidFill>
-                  <a:srgbClr val="1F3864"/>
+              <a:rPr sz="4000" b="0" i="0">
+                <a:solidFill>
+                  <a:srgbClr val="FFFFFF"/>
                 </a:solidFill>
                 <a:latin typeface="Georgia"/>
               </a:rPr>
-              <a:t>India: </a:t>
-            </a:r>
-            <a:r>
-              <a:rPr sz="3000" b="0" i="0">
-                <a:solidFill>
-                  <a:srgbClr val="1F3864"/>
-                </a:solidFill>
-                <a:latin typeface="Georgia"/>
-              </a:rPr>
-              <a:t>2024-25 </a:t>
-            </a:r>
-            <a:r>
-              <a:rPr sz="3000" b="0" i="0">
-                <a:solidFill>
-                  <a:srgbClr val="1F3864"/>
-                </a:solidFill>
-                <a:latin typeface="Georgia"/>
-              </a:rPr>
-              <a:t>Impact</a:t>
+              <a:t>India:</a:t>
             </a:r>
           </a:p>
           <a:p>
             <a:pPr algn="l">
               <a:lnSpc>
-                <a:spcPts val="3408"/>
+                <a:spcPts val="4544"/>
               </a:lnSpc>
               <a:spcBef>
                 <a:spcPts val="0"/>
@@ -3246,12 +3270,30 @@
               </a:spcAft>
             </a:pPr>
             <a:r>
-              <a:rPr sz="3000" b="0" i="0">
-                <a:solidFill>
-                  <a:srgbClr val="1F3864"/>
+              <a:rPr sz="4000" b="0" i="0">
+                <a:solidFill>
+                  <a:srgbClr val="FFFFFF"/>
                 </a:solidFill>
                 <a:latin typeface="Georgia"/>
               </a:rPr>
+              <a:t>2024-25 </a:t>
+            </a:r>
+            <a:r>
+              <a:rPr sz="4000" b="0" i="0">
+                <a:solidFill>
+                  <a:srgbClr val="FFFFFF"/>
+                </a:solidFill>
+                <a:latin typeface="Georgia"/>
+              </a:rPr>
+              <a:t>Impact </a:t>
+            </a:r>
+            <a:r>
+              <a:rPr sz="4000" b="0" i="0">
+                <a:solidFill>
+                  <a:srgbClr val="FFFFFF"/>
+                </a:solidFill>
+                <a:latin typeface="Georgia"/>
+              </a:rPr>
               <a:t>Review</a:t>
             </a:r>
           </a:p>
@@ -3259,14 +3301,14 @@
       </p:sp>
       <p:sp>
         <p:nvSpPr>
-          <p:cNvPr id="4" name="TextBox 3"/>
+          <p:cNvPr id="5" name="TextBox 4"/>
           <p:cNvSpPr txBox="1"/>
           <p:nvPr/>
         </p:nvSpPr>
         <p:spPr>
           <a:xfrm>
-            <a:off x="914400" y="3609008"/>
-            <a:ext cx="10363200" cy="236488"/>
+            <a:off x="1005840" y="2635738"/>
+            <a:ext cx="10180320" cy="236488"/>
           </a:xfrm>
           <a:prstGeom prst="rect">
             <a:avLst/>
@@ -3293,7 +3335,7 @@
             <a:r>
               <a:rPr sz="1400" b="0" i="0">
                 <a:solidFill>
-                  <a:srgbClr val="757575"/>
+                  <a:srgbClr val="FFFFFF"/>
                 </a:solidFill>
                 <a:latin typeface="Segoe UI"/>
               </a:rPr>
@@ -3302,7 +3344,7 @@
             <a:r>
               <a:rPr sz="1400" b="0" i="0">
                 <a:solidFill>
-                  <a:srgbClr val="757575"/>
+                  <a:srgbClr val="FFFFFF"/>
                 </a:solidFill>
                 <a:latin typeface="Segoe UI"/>
               </a:rPr>
@@ -3311,7 +3353,7 @@
             <a:r>
               <a:rPr sz="1400" b="0" i="0">
                 <a:solidFill>
-                  <a:srgbClr val="757575"/>
+                  <a:srgbClr val="FFFFFF"/>
                 </a:solidFill>
                 <a:latin typeface="Segoe UI"/>
               </a:rPr>
@@ -3320,7 +3362,7 @@
             <a:r>
               <a:rPr sz="1400" b="0" i="0">
                 <a:solidFill>
-                  <a:srgbClr val="757575"/>
+                  <a:srgbClr val="FFFFFF"/>
                 </a:solidFill>
                 <a:latin typeface="Segoe UI"/>
               </a:rPr>
@@ -3329,7 +3371,7 @@
             <a:r>
               <a:rPr sz="1400" b="0" i="0">
                 <a:solidFill>
-                  <a:srgbClr val="757575"/>
+                  <a:srgbClr val="FFFFFF"/>
                 </a:solidFill>
                 <a:latin typeface="Segoe UI"/>
               </a:rPr>
@@ -3338,7 +3380,7 @@
             <a:r>
               <a:rPr sz="1400" b="0" i="0">
                 <a:solidFill>
-                  <a:srgbClr val="757575"/>
+                  <a:srgbClr val="FFFFFF"/>
                 </a:solidFill>
                 <a:latin typeface="Segoe UI"/>
               </a:rPr>
@@ -3347,7 +3389,7 @@
             <a:r>
               <a:rPr sz="1400" b="0" i="0">
                 <a:solidFill>
-                  <a:srgbClr val="757575"/>
+                  <a:srgbClr val="FFFFFF"/>
                 </a:solidFill>
                 <a:latin typeface="Segoe UI"/>
               </a:rPr>
@@ -3356,7 +3398,7 @@
             <a:r>
               <a:rPr sz="1400" b="0" i="0">
                 <a:solidFill>
-                  <a:srgbClr val="757575"/>
+                  <a:srgbClr val="FFFFFF"/>
                 </a:solidFill>
                 <a:latin typeface="Segoe UI"/>
               </a:rPr>
@@ -3365,7 +3407,7 @@
             <a:r>
               <a:rPr sz="1400" b="0" i="0">
                 <a:solidFill>
-                  <a:srgbClr val="757575"/>
+                  <a:srgbClr val="FFFFFF"/>
                 </a:solidFill>
                 <a:latin typeface="Segoe UI"/>
               </a:rPr>
@@ -3374,7 +3416,7 @@
             <a:r>
               <a:rPr sz="1400" b="0" i="0">
                 <a:solidFill>
-                  <a:srgbClr val="757575"/>
+                  <a:srgbClr val="FFFFFF"/>
                 </a:solidFill>
                 <a:latin typeface="Segoe UI"/>
               </a:rPr>
@@ -3385,14 +3427,14 @@
       </p:sp>
       <p:sp>
         <p:nvSpPr>
-          <p:cNvPr id="5" name="TextBox 4"/>
+          <p:cNvPr id="6" name="TextBox 5"/>
           <p:cNvSpPr txBox="1"/>
           <p:nvPr/>
         </p:nvSpPr>
         <p:spPr>
           <a:xfrm>
-            <a:off x="914400" y="6035040"/>
-            <a:ext cx="10363200" cy="274320"/>
+            <a:off x="1005840" y="4572000"/>
+            <a:ext cx="10180320" cy="548640"/>
           </a:xfrm>
           <a:prstGeom prst="rect">
             <a:avLst/>
@@ -3416,11 +3458,11 @@
             <a:r>
               <a:rPr sz="900" b="0" i="0">
                 <a:solidFill>
-                  <a:srgbClr val="757575"/>
-                </a:solidFill>
-                <a:latin typeface="Segoe UI"/>
-              </a:rPr>
-              <a:t>6 July 2026 | DeckEngine Demo</a:t>
+                  <a:srgbClr val="FFFFFF"/>
+                </a:solidFill>
+                <a:latin typeface="Segoe UI"/>
+              </a:rPr>
+              <a:t>DeckEngine Demo</a:t>
             </a:r>
           </a:p>
         </p:txBody>
@@ -4978,13 +5020,13 @@
         <p:spPr>
           <a:xfrm>
             <a:off x="0" y="0"/>
-            <a:ext cx="164592" cy="6858000"/>
+            <a:ext cx="12192000" cy="6858000"/>
           </a:xfrm>
           <a:prstGeom prst="rect">
             <a:avLst/>
           </a:prstGeom>
           <a:solidFill>
-            <a:srgbClr val="1F3864"/>
+            <a:srgbClr val="C55A11"/>
           </a:solidFill>
           <a:ln>
             <a:noFill/>
@@ -5021,8 +5063,8 @@
         </p:nvSpPr>
         <p:spPr>
           <a:xfrm>
-            <a:off x="914400" y="1463040"/>
-            <a:ext cx="10180320" cy="731520"/>
+            <a:off x="1371600" y="1600200"/>
+            <a:ext cx="9448800" cy="777240"/>
           </a:xfrm>
           <a:prstGeom prst="rect">
             <a:avLst/>
@@ -5035,7 +5077,7 @@
           </a:bodyPr>
           <a:lstStyle/>
           <a:p>
-            <a:pPr algn="l">
+            <a:pPr algn="ctr">
               <a:spcBef>
                 <a:spcPts val="0"/>
               </a:spcBef>
@@ -5046,7 +5088,7 @@
             <a:r>
               <a:rPr sz="4000" b="1" i="0">
                 <a:solidFill>
-                  <a:srgbClr val="C55A11"/>
+                  <a:srgbClr val="FFFFFF"/>
                 </a:solidFill>
                 <a:latin typeface="Georgia"/>
               </a:rPr>
@@ -5063,8 +5105,8 @@
         </p:nvSpPr>
         <p:spPr>
           <a:xfrm>
-            <a:off x="914400" y="2286000"/>
-            <a:ext cx="10180320" cy="375183"/>
+            <a:off x="1371600" y="2468880"/>
+            <a:ext cx="9448800" cy="432904"/>
           </a:xfrm>
           <a:prstGeom prst="rect">
             <a:avLst/>
@@ -5077,9 +5119,9 @@
           </a:bodyPr>
           <a:lstStyle/>
           <a:p>
-            <a:pPr algn="l">
+            <a:pPr algn="ctr">
               <a:lnSpc>
-                <a:spcPts val="2954"/>
+                <a:spcPts val="3408"/>
               </a:lnSpc>
               <a:spcBef>
                 <a:spcPts val="0"/>
@@ -5089,18 +5131,18 @@
               </a:spcAft>
             </a:pPr>
             <a:r>
-              <a:rPr sz="2600" b="0" i="0">
-                <a:solidFill>
-                  <a:srgbClr val="1F3864"/>
+              <a:rPr sz="3000" b="0" i="0">
+                <a:solidFill>
+                  <a:srgbClr val="FFFFFF"/>
                 </a:solidFill>
                 <a:latin typeface="Georgia"/>
               </a:rPr>
               <a:t>State-level </a:t>
             </a:r>
             <a:r>
-              <a:rPr sz="2600" b="0" i="0">
-                <a:solidFill>
-                  <a:srgbClr val="1F3864"/>
+              <a:rPr sz="3000" b="0" i="0">
+                <a:solidFill>
+                  <a:srgbClr val="FFFFFF"/>
                 </a:solidFill>
                 <a:latin typeface="Georgia"/>
               </a:rPr>
@@ -5117,8 +5159,8 @@
         </p:nvSpPr>
         <p:spPr>
           <a:xfrm>
-            <a:off x="914400" y="2752623"/>
-            <a:ext cx="10180320" cy="236488"/>
+            <a:off x="1371600" y="2993224"/>
+            <a:ext cx="9448800" cy="236488"/>
           </a:xfrm>
           <a:prstGeom prst="rect">
             <a:avLst/>
@@ -5131,7 +5173,7 @@
           </a:bodyPr>
           <a:lstStyle/>
           <a:p>
-            <a:pPr algn="l">
+            <a:pPr algn="ctr">
               <a:lnSpc>
                 <a:spcPts val="1862"/>
               </a:lnSpc>
@@ -5145,7 +5187,7 @@
             <a:r>
               <a:rPr sz="1400" b="0" i="0">
                 <a:solidFill>
-                  <a:srgbClr val="757575"/>
+                  <a:srgbClr val="FFFFFF"/>
                 </a:solidFill>
                 <a:latin typeface="Segoe UI"/>
               </a:rPr>
@@ -5154,7 +5196,7 @@
             <a:r>
               <a:rPr sz="1400" b="0" i="0">
                 <a:solidFill>
-                  <a:srgbClr val="757575"/>
+                  <a:srgbClr val="FFFFFF"/>
                 </a:solidFill>
                 <a:latin typeface="Segoe UI"/>
               </a:rPr>
@@ -5163,7 +5205,7 @@
             <a:r>
               <a:rPr sz="1400" b="0" i="0">
                 <a:solidFill>
-                  <a:srgbClr val="757575"/>
+                  <a:srgbClr val="FFFFFF"/>
                 </a:solidFill>
                 <a:latin typeface="Segoe UI"/>
               </a:rPr>
@@ -5172,7 +5214,7 @@
             <a:r>
               <a:rPr sz="1400" b="0" i="0">
                 <a:solidFill>
-                  <a:srgbClr val="757575"/>
+                  <a:srgbClr val="FFFFFF"/>
                 </a:solidFill>
                 <a:latin typeface="Segoe UI"/>
               </a:rPr>
@@ -5181,7 +5223,7 @@
             <a:r>
               <a:rPr sz="1400" b="0" i="0">
                 <a:solidFill>
-                  <a:srgbClr val="757575"/>
+                  <a:srgbClr val="FFFFFF"/>
                 </a:solidFill>
                 <a:latin typeface="Segoe UI"/>
               </a:rPr>
@@ -5190,7 +5232,7 @@
             <a:r>
               <a:rPr sz="1400" b="0" i="0">
                 <a:solidFill>
-                  <a:srgbClr val="757575"/>
+                  <a:srgbClr val="FFFFFF"/>
                 </a:solidFill>
                 <a:latin typeface="Segoe UI"/>
               </a:rPr>
@@ -5199,7 +5241,7 @@
             <a:r>
               <a:rPr sz="1400" b="0" i="0">
                 <a:solidFill>
-                  <a:srgbClr val="757575"/>
+                  <a:srgbClr val="FFFFFF"/>
                 </a:solidFill>
                 <a:latin typeface="Segoe UI"/>
               </a:rPr>
@@ -5208,7 +5250,7 @@
             <a:r>
               <a:rPr sz="1400" b="0" i="0">
                 <a:solidFill>
-                  <a:srgbClr val="757575"/>
+                  <a:srgbClr val="FFFFFF"/>
                 </a:solidFill>
                 <a:latin typeface="Segoe UI"/>
               </a:rPr>
@@ -5217,7 +5259,7 @@
             <a:r>
               <a:rPr sz="1400" b="0" i="0">
                 <a:solidFill>
-                  <a:srgbClr val="757575"/>
+                  <a:srgbClr val="FFFFFF"/>
                 </a:solidFill>
                 <a:latin typeface="Segoe UI"/>
               </a:rPr>

</xml_diff>

<commit_message>
Q1b: KPI dashboard uses banded icon tiles + shadowed cards; brace/arrow shapes
- kpi_dashboard renders icon_stats as an icon_tile_row (dark tiles + bands)
  instead of stacked rows — reads hand-built like the reference impact slide
- kpi_card_strip cards + highlight_box panels get soft drop-shadows (float)
- pptx_shapes: right_brace/left_brace/notched_arrow presets for connectors
- impact dashboard now matches reference slide 4 craft: pills, tiles, cards,
  accent-bar highlight, superscripts

131 tests; eval green; COM-verified.
</commit_message>
<xml_diff>
--- a/eval/out/agdev_demo.pptx
+++ b/eval/out/agdev_demo.pptx
@@ -21269,17 +21269,63 @@
       </p:sp>
       <p:sp>
         <p:nvSpPr>
-          <p:cNvPr id="3" name="Oval 2"/>
+          <p:cNvPr id="3" name="Rectangle 2"/>
           <p:cNvSpPr/>
           <p:nvPr/>
         </p:nvSpPr>
         <p:spPr>
           <a:xfrm>
-            <a:off x="411480" y="1463040"/>
-            <a:ext cx="384048" cy="384048"/>
-          </a:xfrm>
-          <a:prstGeom prst="ellipse">
-            <a:avLst/>
+            <a:off x="411480" y="1099333"/>
+            <a:ext cx="11369040" cy="548640"/>
+          </a:xfrm>
+          <a:prstGeom prst="rect">
+            <a:avLst/>
+          </a:prstGeom>
+          <a:solidFill>
+            <a:srgbClr val="F2F3F5"/>
+          </a:solidFill>
+          <a:ln>
+            <a:noFill/>
+          </a:ln>
+          <a:effectLst/>
+        </p:spPr>
+        <p:style>
+          <a:lnRef idx="1">
+            <a:schemeClr val="accent1"/>
+          </a:lnRef>
+          <a:fillRef idx="3">
+            <a:schemeClr val="accent1"/>
+          </a:fillRef>
+          <a:effectRef idx="2">
+            <a:schemeClr val="accent1"/>
+          </a:effectRef>
+          <a:fontRef idx="minor">
+            <a:schemeClr val="lt1"/>
+          </a:fontRef>
+        </p:style>
+        <p:txBody>
+          <a:bodyPr rtlCol="0" anchor="ctr"/>
+          <a:lstStyle/>
+          <a:p>
+            <a:pPr algn="ctr"/>
+          </a:p>
+        </p:txBody>
+      </p:sp>
+      <p:sp>
+        <p:nvSpPr>
+          <p:cNvPr id="4" name="Rounded Rectangle 3"/>
+          <p:cNvSpPr/>
+          <p:nvPr/>
+        </p:nvSpPr>
+        <p:spPr>
+          <a:xfrm>
+            <a:off x="457200" y="1122193"/>
+            <a:ext cx="502920" cy="502920"/>
+          </a:xfrm>
+          <a:prstGeom prst="roundRect">
+            <a:avLst>
+              <a:gd name="adj" fmla="val 18000"/>
+            </a:avLst>
           </a:prstGeom>
           <a:solidFill>
             <a:srgbClr val="16294A"/>
@@ -21304,41 +21350,23 @@
           </a:fontRef>
         </p:style>
         <p:txBody>
-          <a:bodyPr rtlCol="0" anchor="ctr" wrap="square" lIns="0" rIns="0" tIns="0" bIns="0">
-            <a:noAutofit/>
-          </a:bodyPr>
-          <a:lstStyle/>
-          <a:p>
-            <a:pPr algn="ctr">
-              <a:spcBef>
-                <a:spcPts val="0"/>
-              </a:spcBef>
-              <a:spcAft>
-                <a:spcPts val="0"/>
-              </a:spcAft>
-            </a:pPr>
-            <a:r>
-              <a:rPr sz="1400" b="0" i="0">
-                <a:solidFill>
-                  <a:srgbClr val="FFFFFF"/>
-                </a:solidFill>
-                <a:latin typeface="Segoe UI"/>
-              </a:rPr>
-              <a:t>👥</a:t>
-            </a:r>
-          </a:p>
-        </p:txBody>
-      </p:sp>
-      <p:sp>
-        <p:nvSpPr>
-          <p:cNvPr id="4" name="TextBox 3"/>
+          <a:bodyPr rtlCol="0" anchor="ctr"/>
+          <a:lstStyle/>
+          <a:p>
+            <a:pPr algn="ctr"/>
+          </a:p>
+        </p:txBody>
+      </p:sp>
+      <p:sp>
+        <p:nvSpPr>
+          <p:cNvPr id="5" name="TextBox 4"/>
           <p:cNvSpPr txBox="1"/>
           <p:nvPr/>
         </p:nvSpPr>
         <p:spPr>
           <a:xfrm>
-            <a:off x="850392" y="1463040"/>
-            <a:ext cx="2404628" cy="384048"/>
+            <a:off x="1014984" y="1099333"/>
+            <a:ext cx="391634" cy="548640"/>
           </a:xfrm>
           <a:prstGeom prst="rect">
             <a:avLst/>
@@ -21352,9 +21380,6 @@
           <a:lstStyle/>
           <a:p>
             <a:pPr algn="l">
-              <a:lnSpc>
-                <a:spcPts val="1795"/>
-              </a:lnSpc>
               <a:spcBef>
                 <a:spcPts val="0"/>
               </a:spcBef>
@@ -21376,14 +21401,14 @@
       </p:sp>
       <p:sp>
         <p:nvSpPr>
-          <p:cNvPr id="5" name="TextBox 4"/>
+          <p:cNvPr id="6" name="TextBox 5"/>
           <p:cNvSpPr txBox="1"/>
           <p:nvPr/>
         </p:nvSpPr>
         <p:spPr>
           <a:xfrm>
-            <a:off x="3309884" y="1463040"/>
-            <a:ext cx="8470636" cy="384048"/>
+            <a:off x="1406618" y="1297639"/>
+            <a:ext cx="10328182" cy="152028"/>
           </a:xfrm>
           <a:prstGeom prst="rect">
             <a:avLst/>
@@ -21391,7 +21416,7 @@
           <a:noFill/>
         </p:spPr>
         <p:txBody>
-          <a:bodyPr wrap="square" lIns="0" rIns="0" tIns="0" bIns="0" anchor="ctr">
+          <a:bodyPr wrap="square" lIns="0" rIns="0" tIns="0" bIns="0" anchor="t">
             <a:noAutofit/>
           </a:bodyPr>
           <a:lstStyle/>
@@ -21457,17 +21482,63 @@
       </p:sp>
       <p:sp>
         <p:nvSpPr>
-          <p:cNvPr id="6" name="Oval 5"/>
+          <p:cNvPr id="7" name="Rectangle 6"/>
           <p:cNvSpPr/>
           <p:nvPr/>
         </p:nvSpPr>
         <p:spPr>
           <a:xfrm>
-            <a:off x="411480" y="1956816"/>
-            <a:ext cx="384048" cy="384048"/>
-          </a:xfrm>
-          <a:prstGeom prst="ellipse">
-            <a:avLst/>
+            <a:off x="411480" y="1675405"/>
+            <a:ext cx="11369040" cy="548640"/>
+          </a:xfrm>
+          <a:prstGeom prst="rect">
+            <a:avLst/>
+          </a:prstGeom>
+          <a:solidFill>
+            <a:srgbClr val="E8EBEF"/>
+          </a:solidFill>
+          <a:ln>
+            <a:noFill/>
+          </a:ln>
+          <a:effectLst/>
+        </p:spPr>
+        <p:style>
+          <a:lnRef idx="1">
+            <a:schemeClr val="accent1"/>
+          </a:lnRef>
+          <a:fillRef idx="3">
+            <a:schemeClr val="accent1"/>
+          </a:fillRef>
+          <a:effectRef idx="2">
+            <a:schemeClr val="accent1"/>
+          </a:effectRef>
+          <a:fontRef idx="minor">
+            <a:schemeClr val="lt1"/>
+          </a:fontRef>
+        </p:style>
+        <p:txBody>
+          <a:bodyPr rtlCol="0" anchor="ctr"/>
+          <a:lstStyle/>
+          <a:p>
+            <a:pPr algn="ctr"/>
+          </a:p>
+        </p:txBody>
+      </p:sp>
+      <p:sp>
+        <p:nvSpPr>
+          <p:cNvPr id="8" name="Rounded Rectangle 7"/>
+          <p:cNvSpPr/>
+          <p:nvPr/>
+        </p:nvSpPr>
+        <p:spPr>
+          <a:xfrm>
+            <a:off x="457200" y="1698265"/>
+            <a:ext cx="502920" cy="502920"/>
+          </a:xfrm>
+          <a:prstGeom prst="roundRect">
+            <a:avLst>
+              <a:gd name="adj" fmla="val 18000"/>
+            </a:avLst>
           </a:prstGeom>
           <a:solidFill>
             <a:srgbClr val="16294A"/>
@@ -21492,41 +21563,23 @@
           </a:fontRef>
         </p:style>
         <p:txBody>
-          <a:bodyPr rtlCol="0" anchor="ctr" wrap="square" lIns="0" rIns="0" tIns="0" bIns="0">
-            <a:noAutofit/>
-          </a:bodyPr>
-          <a:lstStyle/>
-          <a:p>
-            <a:pPr algn="ctr">
-              <a:spcBef>
-                <a:spcPts val="0"/>
-              </a:spcBef>
-              <a:spcAft>
-                <a:spcPts val="0"/>
-              </a:spcAft>
-            </a:pPr>
-            <a:r>
-              <a:rPr sz="1400" b="0" i="0">
-                <a:solidFill>
-                  <a:srgbClr val="FFFFFF"/>
-                </a:solidFill>
-                <a:latin typeface="Segoe UI"/>
-              </a:rPr>
-              <a:t>💰</a:t>
-            </a:r>
-          </a:p>
-        </p:txBody>
-      </p:sp>
-      <p:sp>
-        <p:nvSpPr>
-          <p:cNvPr id="7" name="TextBox 6"/>
+          <a:bodyPr rtlCol="0" anchor="ctr"/>
+          <a:lstStyle/>
+          <a:p>
+            <a:pPr algn="ctr"/>
+          </a:p>
+        </p:txBody>
+      </p:sp>
+      <p:sp>
+        <p:nvSpPr>
+          <p:cNvPr id="9" name="TextBox 8"/>
           <p:cNvSpPr txBox="1"/>
           <p:nvPr/>
         </p:nvSpPr>
         <p:spPr>
           <a:xfrm>
-            <a:off x="850392" y="1956816"/>
-            <a:ext cx="2404628" cy="384048"/>
+            <a:off x="1014984" y="1675405"/>
+            <a:ext cx="440189" cy="548640"/>
           </a:xfrm>
           <a:prstGeom prst="rect">
             <a:avLst/>
@@ -21540,9 +21593,6 @@
           <a:lstStyle/>
           <a:p>
             <a:pPr algn="l">
-              <a:lnSpc>
-                <a:spcPts val="1795"/>
-              </a:lnSpc>
               <a:spcBef>
                 <a:spcPts val="0"/>
               </a:spcBef>
@@ -21564,14 +21614,14 @@
       </p:sp>
       <p:sp>
         <p:nvSpPr>
-          <p:cNvPr id="8" name="TextBox 7"/>
+          <p:cNvPr id="10" name="TextBox 9"/>
           <p:cNvSpPr txBox="1"/>
           <p:nvPr/>
         </p:nvSpPr>
         <p:spPr>
           <a:xfrm>
-            <a:off x="3309884" y="1956816"/>
-            <a:ext cx="8470636" cy="384048"/>
+            <a:off x="1455173" y="1873711"/>
+            <a:ext cx="10279627" cy="152028"/>
           </a:xfrm>
           <a:prstGeom prst="rect">
             <a:avLst/>
@@ -21579,7 +21629,7 @@
           <a:noFill/>
         </p:spPr>
         <p:txBody>
-          <a:bodyPr wrap="square" lIns="0" rIns="0" tIns="0" bIns="0" anchor="ctr">
+          <a:bodyPr wrap="square" lIns="0" rIns="0" tIns="0" bIns="0" anchor="t">
             <a:noAutofit/>
           </a:bodyPr>
           <a:lstStyle/>
@@ -21690,17 +21740,63 @@
       </p:sp>
       <p:sp>
         <p:nvSpPr>
-          <p:cNvPr id="9" name="Oval 8"/>
+          <p:cNvPr id="11" name="Rectangle 10"/>
           <p:cNvSpPr/>
           <p:nvPr/>
         </p:nvSpPr>
         <p:spPr>
           <a:xfrm>
-            <a:off x="411480" y="2450592"/>
-            <a:ext cx="384048" cy="384048"/>
-          </a:xfrm>
-          <a:prstGeom prst="ellipse">
-            <a:avLst/>
+            <a:off x="411480" y="2251477"/>
+            <a:ext cx="11369040" cy="548640"/>
+          </a:xfrm>
+          <a:prstGeom prst="rect">
+            <a:avLst/>
+          </a:prstGeom>
+          <a:solidFill>
+            <a:srgbClr val="F2F3F5"/>
+          </a:solidFill>
+          <a:ln>
+            <a:noFill/>
+          </a:ln>
+          <a:effectLst/>
+        </p:spPr>
+        <p:style>
+          <a:lnRef idx="1">
+            <a:schemeClr val="accent1"/>
+          </a:lnRef>
+          <a:fillRef idx="3">
+            <a:schemeClr val="accent1"/>
+          </a:fillRef>
+          <a:effectRef idx="2">
+            <a:schemeClr val="accent1"/>
+          </a:effectRef>
+          <a:fontRef idx="minor">
+            <a:schemeClr val="lt1"/>
+          </a:fontRef>
+        </p:style>
+        <p:txBody>
+          <a:bodyPr rtlCol="0" anchor="ctr"/>
+          <a:lstStyle/>
+          <a:p>
+            <a:pPr algn="ctr"/>
+          </a:p>
+        </p:txBody>
+      </p:sp>
+      <p:sp>
+        <p:nvSpPr>
+          <p:cNvPr id="12" name="Rounded Rectangle 11"/>
+          <p:cNvSpPr/>
+          <p:nvPr/>
+        </p:nvSpPr>
+        <p:spPr>
+          <a:xfrm>
+            <a:off x="457200" y="2274337"/>
+            <a:ext cx="502920" cy="502920"/>
+          </a:xfrm>
+          <a:prstGeom prst="roundRect">
+            <a:avLst>
+              <a:gd name="adj" fmla="val 18000"/>
+            </a:avLst>
           </a:prstGeom>
           <a:solidFill>
             <a:srgbClr val="16294A"/>
@@ -21725,41 +21821,23 @@
           </a:fontRef>
         </p:style>
         <p:txBody>
-          <a:bodyPr rtlCol="0" anchor="ctr" wrap="square" lIns="0" rIns="0" tIns="0" bIns="0">
-            <a:noAutofit/>
-          </a:bodyPr>
-          <a:lstStyle/>
-          <a:p>
-            <a:pPr algn="ctr">
-              <a:spcBef>
-                <a:spcPts val="0"/>
-              </a:spcBef>
-              <a:spcAft>
-                <a:spcPts val="0"/>
-              </a:spcAft>
-            </a:pPr>
-            <a:r>
-              <a:rPr sz="1400" b="0" i="0">
-                <a:solidFill>
-                  <a:srgbClr val="FFFFFF"/>
-                </a:solidFill>
-                <a:latin typeface="Segoe UI"/>
-              </a:rPr>
-              <a:t>📈</a:t>
-            </a:r>
-          </a:p>
-        </p:txBody>
-      </p:sp>
-      <p:sp>
-        <p:nvSpPr>
-          <p:cNvPr id="10" name="TextBox 9"/>
+          <a:bodyPr rtlCol="0" anchor="ctr"/>
+          <a:lstStyle/>
+          <a:p>
+            <a:pPr algn="ctr"/>
+          </a:p>
+        </p:txBody>
+      </p:sp>
+      <p:sp>
+        <p:nvSpPr>
+          <p:cNvPr id="13" name="TextBox 12"/>
           <p:cNvSpPr txBox="1"/>
           <p:nvPr/>
         </p:nvSpPr>
         <p:spPr>
           <a:xfrm>
-            <a:off x="850392" y="2450592"/>
-            <a:ext cx="2404628" cy="384048"/>
+            <a:off x="1014984" y="2251477"/>
+            <a:ext cx="756802" cy="548640"/>
           </a:xfrm>
           <a:prstGeom prst="rect">
             <a:avLst/>
@@ -21773,9 +21851,6 @@
           <a:lstStyle/>
           <a:p>
             <a:pPr algn="l">
-              <a:lnSpc>
-                <a:spcPts val="1795"/>
-              </a:lnSpc>
               <a:spcBef>
                 <a:spcPts val="0"/>
               </a:spcBef>
@@ -21797,14 +21872,14 @@
       </p:sp>
       <p:sp>
         <p:nvSpPr>
-          <p:cNvPr id="11" name="TextBox 10"/>
+          <p:cNvPr id="14" name="TextBox 13"/>
           <p:cNvSpPr txBox="1"/>
           <p:nvPr/>
         </p:nvSpPr>
         <p:spPr>
           <a:xfrm>
-            <a:off x="3309884" y="2450592"/>
-            <a:ext cx="8470636" cy="384048"/>
+            <a:off x="1771786" y="2449783"/>
+            <a:ext cx="9963014" cy="152028"/>
           </a:xfrm>
           <a:prstGeom prst="rect">
             <a:avLst/>
@@ -21812,7 +21887,7 @@
           <a:noFill/>
         </p:spPr>
         <p:txBody>
-          <a:bodyPr wrap="square" lIns="0" rIns="0" tIns="0" bIns="0" anchor="ctr">
+          <a:bodyPr wrap="square" lIns="0" rIns="0" tIns="0" bIns="0" anchor="t">
             <a:noAutofit/>
           </a:bodyPr>
           <a:lstStyle/>
@@ -21887,13 +21962,13 @@
       </p:sp>
       <p:sp>
         <p:nvSpPr>
-          <p:cNvPr id="12" name="Rectangle 11"/>
+          <p:cNvPr id="15" name="Rectangle 14"/>
           <p:cNvSpPr/>
           <p:nvPr/>
         </p:nvSpPr>
         <p:spPr>
           <a:xfrm>
-            <a:off x="411480" y="3054096"/>
+            <a:off x="411480" y="3602174"/>
             <a:ext cx="2807970" cy="1234440"/>
           </a:xfrm>
           <a:prstGeom prst="rect">
@@ -21905,7 +21980,13 @@
           <a:ln>
             <a:noFill/>
           </a:ln>
-          <a:effectLst/>
+          <a:effectLst>
+            <a:outerShdw blurRad="40000" dist="24000" dir="5400000" rotWithShape="0">
+              <a:srgbClr val="1A1A1A">
+                <a:alpha val="62000"/>
+              </a:srgbClr>
+            </a:outerShdw>
+          </a:effectLst>
         </p:spPr>
         <p:style>
           <a:lnRef idx="1">
@@ -22059,13 +22140,13 @@
       </p:sp>
       <p:sp>
         <p:nvSpPr>
-          <p:cNvPr id="13" name="Rectangle 12"/>
+          <p:cNvPr id="16" name="Rectangle 15"/>
           <p:cNvSpPr/>
           <p:nvPr/>
         </p:nvSpPr>
         <p:spPr>
           <a:xfrm>
-            <a:off x="3265170" y="3054096"/>
+            <a:off x="3265170" y="3602174"/>
             <a:ext cx="2807970" cy="1234440"/>
           </a:xfrm>
           <a:prstGeom prst="rect">
@@ -22077,7 +22158,13 @@
           <a:ln>
             <a:noFill/>
           </a:ln>
-          <a:effectLst/>
+          <a:effectLst>
+            <a:outerShdw blurRad="40000" dist="24000" dir="5400000" rotWithShape="0">
+              <a:srgbClr val="1A1A1A">
+                <a:alpha val="62000"/>
+              </a:srgbClr>
+            </a:outerShdw>
+          </a:effectLst>
         </p:spPr>
         <p:style>
           <a:lnRef idx="1">
@@ -22213,13 +22300,13 @@
       </p:sp>
       <p:sp>
         <p:nvSpPr>
-          <p:cNvPr id="14" name="Rectangle 13"/>
+          <p:cNvPr id="17" name="Rectangle 16"/>
           <p:cNvSpPr/>
           <p:nvPr/>
         </p:nvSpPr>
         <p:spPr>
           <a:xfrm>
-            <a:off x="6118860" y="3054096"/>
+            <a:off x="6118860" y="3602174"/>
             <a:ext cx="2807970" cy="1234440"/>
           </a:xfrm>
           <a:prstGeom prst="rect">
@@ -22231,7 +22318,13 @@
           <a:ln>
             <a:noFill/>
           </a:ln>
-          <a:effectLst/>
+          <a:effectLst>
+            <a:outerShdw blurRad="40000" dist="24000" dir="5400000" rotWithShape="0">
+              <a:srgbClr val="1A1A1A">
+                <a:alpha val="62000"/>
+              </a:srgbClr>
+            </a:outerShdw>
+          </a:effectLst>
         </p:spPr>
         <p:style>
           <a:lnRef idx="1">
@@ -22367,13 +22460,13 @@
       </p:sp>
       <p:sp>
         <p:nvSpPr>
-          <p:cNvPr id="15" name="Rectangle 14"/>
+          <p:cNvPr id="18" name="Rectangle 17"/>
           <p:cNvSpPr/>
           <p:nvPr/>
         </p:nvSpPr>
         <p:spPr>
           <a:xfrm>
-            <a:off x="8972550" y="3054096"/>
+            <a:off x="8972550" y="3602174"/>
             <a:ext cx="2807970" cy="1234440"/>
           </a:xfrm>
           <a:prstGeom prst="rect">
@@ -22385,7 +22478,13 @@
           <a:ln>
             <a:noFill/>
           </a:ln>
-          <a:effectLst/>
+          <a:effectLst>
+            <a:outerShdw blurRad="40000" dist="24000" dir="5400000" rotWithShape="0">
+              <a:srgbClr val="1A1A1A">
+                <a:alpha val="62000"/>
+              </a:srgbClr>
+            </a:outerShdw>
+          </a:effectLst>
         </p:spPr>
         <p:style>
           <a:lnRef idx="1">
@@ -22530,13 +22629,13 @@
       </p:sp>
       <p:sp>
         <p:nvSpPr>
-          <p:cNvPr id="16" name="Rectangle 15"/>
+          <p:cNvPr id="19" name="Rectangle 18"/>
           <p:cNvSpPr/>
           <p:nvPr/>
         </p:nvSpPr>
         <p:spPr>
           <a:xfrm>
-            <a:off x="411480" y="4590288"/>
+            <a:off x="411480" y="5138366"/>
             <a:ext cx="11369040" cy="857094"/>
           </a:xfrm>
           <a:prstGeom prst="rect">
@@ -22548,7 +22647,13 @@
           <a:ln>
             <a:noFill/>
           </a:ln>
-          <a:effectLst/>
+          <a:effectLst>
+            <a:outerShdw blurRad="40000" dist="24000" dir="5400000" rotWithShape="0">
+              <a:srgbClr val="1A1A1A">
+                <a:alpha val="62000"/>
+              </a:srgbClr>
+            </a:outerShdw>
+          </a:effectLst>
         </p:spPr>
         <p:style>
           <a:lnRef idx="1">
@@ -22574,13 +22679,13 @@
       </p:sp>
       <p:sp>
         <p:nvSpPr>
-          <p:cNvPr id="17" name="Rectangle 16"/>
+          <p:cNvPr id="20" name="Rectangle 19"/>
           <p:cNvSpPr/>
           <p:nvPr/>
         </p:nvSpPr>
         <p:spPr>
           <a:xfrm>
-            <a:off x="411480" y="4590288"/>
+            <a:off x="411480" y="5138366"/>
             <a:ext cx="32004" cy="857094"/>
           </a:xfrm>
           <a:prstGeom prst="rect">
@@ -22618,13 +22723,13 @@
       </p:sp>
       <p:sp>
         <p:nvSpPr>
-          <p:cNvPr id="18" name="TextBox 17"/>
+          <p:cNvPr id="21" name="TextBox 20"/>
           <p:cNvSpPr txBox="1"/>
           <p:nvPr/>
         </p:nvSpPr>
         <p:spPr>
           <a:xfrm>
-            <a:off x="484632" y="4663440"/>
+            <a:off x="484632" y="5211518"/>
             <a:ext cx="11222736" cy="236488"/>
           </a:xfrm>
           <a:prstGeom prst="rect">
@@ -22717,13 +22822,13 @@
       </p:sp>
       <p:sp>
         <p:nvSpPr>
-          <p:cNvPr id="19" name="TextBox 18"/>
+          <p:cNvPr id="22" name="TextBox 21"/>
           <p:cNvSpPr txBox="1"/>
           <p:nvPr/>
         </p:nvSpPr>
         <p:spPr>
           <a:xfrm>
-            <a:off x="484632" y="4936504"/>
+            <a:off x="484632" y="5484582"/>
             <a:ext cx="11222736" cy="152028"/>
           </a:xfrm>
           <a:prstGeom prst="rect">
@@ -22987,13 +23092,13 @@
       </p:sp>
       <p:sp>
         <p:nvSpPr>
-          <p:cNvPr id="20" name="TextBox 19"/>
+          <p:cNvPr id="23" name="TextBox 22"/>
           <p:cNvSpPr txBox="1"/>
           <p:nvPr/>
         </p:nvSpPr>
         <p:spPr>
           <a:xfrm>
-            <a:off x="411480" y="5614250"/>
+            <a:off x="411480" y="6162328"/>
             <a:ext cx="11369040" cy="126690"/>
           </a:xfrm>
           <a:prstGeom prst="rect">
@@ -23068,7 +23173,7 @@
       </p:sp>
       <p:cxnSp>
         <p:nvCxnSpPr>
-          <p:cNvPr id="21" name="Connector 20"/>
+          <p:cNvPr id="24" name="Connector 23"/>
           <p:cNvCxnSpPr/>
           <p:nvPr/>
         </p:nvCxnSpPr>
@@ -23103,7 +23208,7 @@
       </p:cxnSp>
       <p:sp>
         <p:nvSpPr>
-          <p:cNvPr id="22" name="TextBox 21"/>
+          <p:cNvPr id="25" name="TextBox 24"/>
           <p:cNvSpPr txBox="1"/>
           <p:nvPr/>
         </p:nvSpPr>
@@ -23145,7 +23250,7 @@
       </p:sp>
       <p:sp>
         <p:nvSpPr>
-          <p:cNvPr id="23" name="TextBox 22"/>
+          <p:cNvPr id="26" name="TextBox 25"/>
           <p:cNvSpPr txBox="1"/>
           <p:nvPr/>
         </p:nvSpPr>
@@ -23187,7 +23292,7 @@
       </p:sp>
       <p:sp>
         <p:nvSpPr>
-          <p:cNvPr id="24" name="TextBox 23"/>
+          <p:cNvPr id="27" name="TextBox 26"/>
           <p:cNvSpPr txBox="1"/>
           <p:nvPr/>
         </p:nvSpPr>

</xml_diff>